<commit_message>
Rename project to Baton and simplify demo documentation
</commit_message>
<xml_diff>
--- a/docs/demo-slide.pptx
+++ b/docs/demo-slide.pptx
@@ -2,13 +2,13 @@
 <file path=ppt/presentation.xml><?xml version="1.0" encoding="utf-8"?>
 <p:presentation xmlns:p="http://schemas.openxmlformats.org/presentationml/2006/main">
   <p:sldMasterIdLst>
-    <p:sldMasterId xmlns:r="http://schemas.openxmlformats.org/officeDocument/2006/relationships" id="2147483648" r:id="R995433fac64c4736"/>
+    <p:sldMasterId xmlns:r="http://schemas.openxmlformats.org/officeDocument/2006/relationships" id="2147483648" r:id="R85f0a03c1a9d4a6a"/>
   </p:sldMasterIdLst>
   <p:notesMasterIdLst>
-    <p:notesMasterId xmlns:r="http://schemas.openxmlformats.org/officeDocument/2006/relationships" r:id="R716fefc327aa4576"/>
+    <p:notesMasterId xmlns:r="http://schemas.openxmlformats.org/officeDocument/2006/relationships" r:id="R6004789f637c4c40"/>
   </p:notesMasterIdLst>
   <p:sldIdLst>
-    <p:sldId xmlns:r="http://schemas.openxmlformats.org/officeDocument/2006/relationships" id="256" r:id="Rfa6a42705ac84442"/>
+    <p:sldId xmlns:r="http://schemas.openxmlformats.org/officeDocument/2006/relationships" id="256" r:id="Ra82669be13574e16"/>
   </p:sldIdLst>
   <p:sldSz cx="12192000" cy="6858000"/>
   <p:notesSz cx="6858000" cy="9144000"/>
@@ -492,7 +492,7 @@
           </a:p>
           <a:p xmlns:a="http://schemas.openxmlformats.org/drawingml/2006/main">
             <a:r>
-              <a:t>All demo records are fictional and Grateful Dead themed. The prototype uses CSV snapshots, has no live Salesforce connection, and has no measured production impact. Production work would require agreed business rules, scoped access, data-retention controls, broader labeled evaluations, and review before any future CRM update.</a:t>
+              <a:t>All demo records are fictional. The prototype uses CSV snapshots, has no live Salesforce connection, and has no measured production impact. Production work would require agreed business rules, scoped access, data-retention controls, broader labeled evaluations, and review before any future CRM update.</a:t>
             </a:r>
           </a:p>
         </p:txBody>
@@ -560,7 +560,7 @@
   </p:cSld>
   <p:clrMap bg1="lt1" tx1="dk1" bg2="lt2" tx2="dk2" accent1="accent1" accent2="accent2" accent3="accent3" accent4="accent4" accent5="accent5" accent6="accent6" hlink="hlink" folHlink="folHlink"/>
   <p:sldLayoutIdLst>
-    <p:sldLayoutId xmlns:r="http://schemas.openxmlformats.org/officeDocument/2006/relationships" id="2147483649" r:id="R244bebb963bd4bf2"/>
+    <p:sldLayoutId xmlns:r="http://schemas.openxmlformats.org/officeDocument/2006/relationships" id="2147483649" r:id="R8ba87d2d2ca34f78"/>
   </p:sldLayoutIdLst>
   <p:txStyles>
     <p:titleStyle>
@@ -1111,7 +1111,7 @@
           <p:cNvPr id="24" name="title">
             <a:extLst xmlns:a="http://schemas.openxmlformats.org/drawingml/2006/main">
               <a:ext uri="{FF2B5EF4-FFF2-40B4-BE49-F238E27FC236}">
-                <a16:creationId xmlns:a16="http://schemas.microsoft.com/office/drawing/2014/main" id="{7153A1BD-F826-403B-BDF3-5F0BF50381F9}"/>
+                <a16:creationId xmlns:a16="http://schemas.microsoft.com/office/drawing/2014/main" id="{E38F6D36-15D0-49B7-95C1-FAB3049FE1FC}"/>
               </a:ext>
             </a:extLst>
           </p:cNvPr>
@@ -1158,7 +1158,7 @@
                 <a:ea typeface="Arial"/>
                 <a:cs typeface="Arial"/>
               </a:rPr>
-              <a:t>Account Handoff Quality Agent</a:t>
+              <a:t>Baton</a:t>
             </a:r>
           </a:p>
         </p:txBody>
@@ -1168,7 +1168,7 @@
           <p:cNvPr id="2" name="problem">
             <a:extLst xmlns:a="http://schemas.openxmlformats.org/drawingml/2006/main">
               <a:ext uri="{FF2B5EF4-FFF2-40B4-BE49-F238E27FC236}">
-                <a16:creationId xmlns:a16="http://schemas.microsoft.com/office/drawing/2014/main" id="{7F6D4DC5-D741-473D-B151-C28601D8B21B}"/>
+                <a16:creationId xmlns:a16="http://schemas.microsoft.com/office/drawing/2014/main" id="{ECC97863-A017-4B15-8896-9DE6C289A758}"/>
               </a:ext>
             </a:extLst>
           </p:cNvPr>
@@ -1225,7 +1225,7 @@
           <p:cNvPr id="3" name="value">
             <a:extLst xmlns:a="http://schemas.openxmlformats.org/drawingml/2006/main">
               <a:ext uri="{FF2B5EF4-FFF2-40B4-BE49-F238E27FC236}">
-                <a16:creationId xmlns:a16="http://schemas.microsoft.com/office/drawing/2014/main" id="{FB0AE2E5-4666-40EB-9D59-DD4F540AEB4B}"/>
+                <a16:creationId xmlns:a16="http://schemas.microsoft.com/office/drawing/2014/main" id="{3D7714D7-A62A-4815-8E8A-D3549C2D78CD}"/>
               </a:ext>
             </a:extLst>
           </p:cNvPr>
@@ -1282,7 +1282,7 @@
           <p:cNvPr id="4" name="flow-0">
             <a:extLst xmlns:a="http://schemas.openxmlformats.org/drawingml/2006/main">
               <a:ext uri="{FF2B5EF4-FFF2-40B4-BE49-F238E27FC236}">
-                <a16:creationId xmlns:a16="http://schemas.microsoft.com/office/drawing/2014/main" id="{0013B051-980B-4018-B5FE-5DBB80A999FA}"/>
+                <a16:creationId xmlns:a16="http://schemas.microsoft.com/office/drawing/2014/main" id="{164D4A5F-2671-49BF-BFB5-D93E90FA6B64}"/>
               </a:ext>
             </a:extLst>
           </p:cNvPr>
@@ -1339,7 +1339,7 @@
           <p:cNvPr id="5" name="detail-0">
             <a:extLst xmlns:a="http://schemas.openxmlformats.org/drawingml/2006/main">
               <a:ext uri="{FF2B5EF4-FFF2-40B4-BE49-F238E27FC236}">
-                <a16:creationId xmlns:a16="http://schemas.microsoft.com/office/drawing/2014/main" id="{5478019F-1376-4833-BF26-0A115123F8A2}"/>
+                <a16:creationId xmlns:a16="http://schemas.microsoft.com/office/drawing/2014/main" id="{982638D1-28D8-4E30-8E23-3F792D1A08B7}"/>
               </a:ext>
             </a:extLst>
           </p:cNvPr>
@@ -1419,7 +1419,7 @@
           <p:cNvPr id="6" name="flow-1">
             <a:extLst xmlns:a="http://schemas.openxmlformats.org/drawingml/2006/main">
               <a:ext uri="{FF2B5EF4-FFF2-40B4-BE49-F238E27FC236}">
-                <a16:creationId xmlns:a16="http://schemas.microsoft.com/office/drawing/2014/main" id="{9BFA6D19-4ECE-4466-B9F6-1DB870366EFD}"/>
+                <a16:creationId xmlns:a16="http://schemas.microsoft.com/office/drawing/2014/main" id="{C0FF32AB-FE17-403B-BD51-07070C59BB16}"/>
               </a:ext>
             </a:extLst>
           </p:cNvPr>
@@ -1476,7 +1476,7 @@
           <p:cNvPr id="7" name="detail-1">
             <a:extLst xmlns:a="http://schemas.openxmlformats.org/drawingml/2006/main">
               <a:ext uri="{FF2B5EF4-FFF2-40B4-BE49-F238E27FC236}">
-                <a16:creationId xmlns:a16="http://schemas.microsoft.com/office/drawing/2014/main" id="{9A91958A-448D-454F-A878-B0E5D6FD8324}"/>
+                <a16:creationId xmlns:a16="http://schemas.microsoft.com/office/drawing/2014/main" id="{E01F61AD-181D-432E-BABF-F451B7B467AB}"/>
               </a:ext>
             </a:extLst>
           </p:cNvPr>
@@ -1556,7 +1556,7 @@
           <p:cNvPr id="8" name="flow-2">
             <a:extLst xmlns:a="http://schemas.openxmlformats.org/drawingml/2006/main">
               <a:ext uri="{FF2B5EF4-FFF2-40B4-BE49-F238E27FC236}">
-                <a16:creationId xmlns:a16="http://schemas.microsoft.com/office/drawing/2014/main" id="{2794242B-B3FA-469E-A43D-176E68ECEA5A}"/>
+                <a16:creationId xmlns:a16="http://schemas.microsoft.com/office/drawing/2014/main" id="{9E0E87E5-DB26-4E0E-B6CF-6A5D508E74DA}"/>
               </a:ext>
             </a:extLst>
           </p:cNvPr>
@@ -1613,7 +1613,7 @@
           <p:cNvPr id="9" name="detail-2">
             <a:extLst xmlns:a="http://schemas.openxmlformats.org/drawingml/2006/main">
               <a:ext uri="{FF2B5EF4-FFF2-40B4-BE49-F238E27FC236}">
-                <a16:creationId xmlns:a16="http://schemas.microsoft.com/office/drawing/2014/main" id="{5007BA71-D400-4AA7-B410-5C4CDFA1490B}"/>
+                <a16:creationId xmlns:a16="http://schemas.microsoft.com/office/drawing/2014/main" id="{F44AA6E6-0D17-43C5-86FF-E4A869606892}"/>
               </a:ext>
             </a:extLst>
           </p:cNvPr>
@@ -1693,7 +1693,7 @@
           <p:cNvPr id="10" name="flow-3">
             <a:extLst xmlns:a="http://schemas.openxmlformats.org/drawingml/2006/main">
               <a:ext uri="{FF2B5EF4-FFF2-40B4-BE49-F238E27FC236}">
-                <a16:creationId xmlns:a16="http://schemas.microsoft.com/office/drawing/2014/main" id="{19F37BAA-94F3-45EA-898B-F16E38684CFE}"/>
+                <a16:creationId xmlns:a16="http://schemas.microsoft.com/office/drawing/2014/main" id="{AA7D33B8-61EC-4696-BF33-0C24EE399550}"/>
               </a:ext>
             </a:extLst>
           </p:cNvPr>
@@ -1750,7 +1750,7 @@
           <p:cNvPr id="11" name="detail-3">
             <a:extLst xmlns:a="http://schemas.openxmlformats.org/drawingml/2006/main">
               <a:ext uri="{FF2B5EF4-FFF2-40B4-BE49-F238E27FC236}">
-                <a16:creationId xmlns:a16="http://schemas.microsoft.com/office/drawing/2014/main" id="{57922F85-DD14-482F-A484-F0AE657A46F4}"/>
+                <a16:creationId xmlns:a16="http://schemas.microsoft.com/office/drawing/2014/main" id="{A1FD9088-BFB4-4997-A9E3-883BD26E082E}"/>
               </a:ext>
             </a:extLst>
           </p:cNvPr>
@@ -1905,7 +1905,7 @@
           <p:cNvPr id="15" name="demo-label">
             <a:extLst xmlns:a="http://schemas.openxmlformats.org/drawingml/2006/main">
               <a:ext uri="{FF2B5EF4-FFF2-40B4-BE49-F238E27FC236}">
-                <a16:creationId xmlns:a16="http://schemas.microsoft.com/office/drawing/2014/main" id="{82556AA3-0794-4640-8F8D-207B416A4DCB}"/>
+                <a16:creationId xmlns:a16="http://schemas.microsoft.com/office/drawing/2014/main" id="{51705D8F-B390-44D9-8C1B-B55FD2738B95}"/>
               </a:ext>
             </a:extLst>
           </p:cNvPr>
@@ -1962,7 +1962,7 @@
           <p:cNvPr id="16" name="baseline-label">
             <a:extLst xmlns:a="http://schemas.openxmlformats.org/drawingml/2006/main">
               <a:ext uri="{FF2B5EF4-FFF2-40B4-BE49-F238E27FC236}">
-                <a16:creationId xmlns:a16="http://schemas.microsoft.com/office/drawing/2014/main" id="{8E39725B-5B32-4928-B052-177F186177BB}"/>
+                <a16:creationId xmlns:a16="http://schemas.microsoft.com/office/drawing/2014/main" id="{72AACBF5-E583-48B4-AC18-05CF77CABBCC}"/>
               </a:ext>
             </a:extLst>
           </p:cNvPr>
@@ -2019,7 +2019,7 @@
           <p:cNvPr id="17" name="final-label">
             <a:extLst xmlns:a="http://schemas.openxmlformats.org/drawingml/2006/main">
               <a:ext uri="{FF2B5EF4-FFF2-40B4-BE49-F238E27FC236}">
-                <a16:creationId xmlns:a16="http://schemas.microsoft.com/office/drawing/2014/main" id="{1F3022E4-1597-467D-B574-F4ECC403A10A}"/>
+                <a16:creationId xmlns:a16="http://schemas.microsoft.com/office/drawing/2014/main" id="{8491760E-94AC-48F2-90D2-D1511790DFAD}"/>
               </a:ext>
             </a:extLst>
           </p:cNvPr>
@@ -2076,7 +2076,7 @@
           <p:cNvPr id="18" name="baseline-status">
             <a:extLst xmlns:a="http://schemas.openxmlformats.org/drawingml/2006/main">
               <a:ext uri="{FF2B5EF4-FFF2-40B4-BE49-F238E27FC236}">
-                <a16:creationId xmlns:a16="http://schemas.microsoft.com/office/drawing/2014/main" id="{EB51E907-1964-4807-95E4-98F1EE496FBD}"/>
+                <a16:creationId xmlns:a16="http://schemas.microsoft.com/office/drawing/2014/main" id="{6632A932-61FA-4C4C-8F9A-ABA21ADDC3DC}"/>
               </a:ext>
             </a:extLst>
           </p:cNvPr>
@@ -2133,7 +2133,7 @@
           <p:cNvPr id="19" name="final-status">
             <a:extLst xmlns:a="http://schemas.openxmlformats.org/drawingml/2006/main">
               <a:ext uri="{FF2B5EF4-FFF2-40B4-BE49-F238E27FC236}">
-                <a16:creationId xmlns:a16="http://schemas.microsoft.com/office/drawing/2014/main" id="{2E4889A5-A774-4E4F-8F57-96B4186F33D4}"/>
+                <a16:creationId xmlns:a16="http://schemas.microsoft.com/office/drawing/2014/main" id="{6DA10AAE-F411-4583-8D97-3FB9CB13A936}"/>
               </a:ext>
             </a:extLst>
           </p:cNvPr>
@@ -2190,7 +2190,7 @@
           <p:cNvPr id="20" name="conflict">
             <a:extLst xmlns:a="http://schemas.openxmlformats.org/drawingml/2006/main">
               <a:ext uri="{FF2B5EF4-FFF2-40B4-BE49-F238E27FC236}">
-                <a16:creationId xmlns:a16="http://schemas.microsoft.com/office/drawing/2014/main" id="{5AB6EE0C-93A7-4EEA-9A97-41CBF9FA5E9E}"/>
+                <a16:creationId xmlns:a16="http://schemas.microsoft.com/office/drawing/2014/main" id="{420DECAD-8F71-479C-B4AC-12C64DAA3915}"/>
               </a:ext>
             </a:extLst>
           </p:cNvPr>
@@ -2270,7 +2270,7 @@
           <p:cNvPr id="21" name="boundary-label">
             <a:extLst xmlns:a="http://schemas.openxmlformats.org/drawingml/2006/main">
               <a:ext uri="{FF2B5EF4-FFF2-40B4-BE49-F238E27FC236}">
-                <a16:creationId xmlns:a16="http://schemas.microsoft.com/office/drawing/2014/main" id="{E1BD8FAF-DEE2-468D-97BB-8EE4BFC50433}"/>
+                <a16:creationId xmlns:a16="http://schemas.microsoft.com/office/drawing/2014/main" id="{70AE5B6F-2D70-47F9-A707-ABF3F05A7ED6}"/>
               </a:ext>
             </a:extLst>
           </p:cNvPr>
@@ -2327,7 +2327,7 @@
           <p:cNvPr id="22" name="boundary">
             <a:extLst xmlns:a="http://schemas.openxmlformats.org/drawingml/2006/main">
               <a:ext uri="{FF2B5EF4-FFF2-40B4-BE49-F238E27FC236}">
-                <a16:creationId xmlns:a16="http://schemas.microsoft.com/office/drawing/2014/main" id="{A493FA09-CFED-4F10-9060-4E6173C7EC11}"/>
+                <a16:creationId xmlns:a16="http://schemas.microsoft.com/office/drawing/2014/main" id="{86E8B977-E20F-49A8-A58D-C0C6AE7FDE22}"/>
               </a:ext>
             </a:extLst>
           </p:cNvPr>
@@ -2430,7 +2430,7 @@
           <p:cNvPr id="23" name="fictional">
             <a:extLst xmlns:a="http://schemas.openxmlformats.org/drawingml/2006/main">
               <a:ext uri="{FF2B5EF4-FFF2-40B4-BE49-F238E27FC236}">
-                <a16:creationId xmlns:a16="http://schemas.microsoft.com/office/drawing/2014/main" id="{65AF7485-0394-4FC1-8BBA-DF37FDC73928}"/>
+                <a16:creationId xmlns:a16="http://schemas.microsoft.com/office/drawing/2014/main" id="{1EF34044-2447-4BC2-8317-BBBAA8A01B06}"/>
               </a:ext>
             </a:extLst>
           </p:cNvPr>
@@ -2477,7 +2477,7 @@
                 <a:ea typeface="Arial"/>
                 <a:cs typeface="Arial"/>
               </a:rPr>
-              <a:t>Fictional Grateful Dead demo</a:t>
+              <a:t>Fictional demo data</a:t>
             </a:r>
           </a:p>
         </p:txBody>
@@ -2485,7 +2485,7 @@
     </p:spTree>
     <p:extLst>
       <p:ext uri="{BB962C8B-B14F-4D97-AF65-F5344CB8AC3E}">
-        <p14:creationId xmlns:p14="http://schemas.microsoft.com/office/powerpoint/2010/main" val="538061141"/>
+        <p14:creationId xmlns:p14="http://schemas.microsoft.com/office/powerpoint/2010/main" val="681122921"/>
       </p:ext>
     </p:extLst>
   </p:cSld>

</xml_diff>

<commit_message>
Add account handoff deck workflow and demo materials
</commit_message>
<xml_diff>
--- a/docs/demo-slide.pptx
+++ b/docs/demo-slide.pptx
@@ -2,13 +2,13 @@
 <file path=ppt/presentation.xml><?xml version="1.0" encoding="utf-8"?>
 <p:presentation xmlns:p="http://schemas.openxmlformats.org/presentationml/2006/main">
   <p:sldMasterIdLst>
-    <p:sldMasterId xmlns:r="http://schemas.openxmlformats.org/officeDocument/2006/relationships" id="2147483648" r:id="R85f0a03c1a9d4a6a"/>
+    <p:sldMasterId xmlns:r="http://schemas.openxmlformats.org/officeDocument/2006/relationships" id="2147483648" r:id="R623dec2bd1f9485e"/>
   </p:sldMasterIdLst>
   <p:notesMasterIdLst>
-    <p:notesMasterId xmlns:r="http://schemas.openxmlformats.org/officeDocument/2006/relationships" r:id="R6004789f637c4c40"/>
+    <p:notesMasterId xmlns:r="http://schemas.openxmlformats.org/officeDocument/2006/relationships" r:id="R3a02a3a0f69c4b79"/>
   </p:notesMasterIdLst>
   <p:sldIdLst>
-    <p:sldId xmlns:r="http://schemas.openxmlformats.org/officeDocument/2006/relationships" id="256" r:id="Ra82669be13574e16"/>
+    <p:sldId xmlns:r="http://schemas.openxmlformats.org/officeDocument/2006/relationships" id="256" r:id="R6a0b72d102b14a7e"/>
   </p:sldIdLst>
   <p:sldSz cx="12192000" cy="6858000"/>
   <p:notesSz cx="6858000" cy="9144000"/>
@@ -442,57 +442,37 @@
           <a:lstStyle xmlns:a="http://schemas.openxmlformats.org/drawingml/2006/main"/>
           <a:p xmlns:a="http://schemas.openxmlformats.org/drawingml/2006/main">
             <a:r>
-              <a:t>This prototype reviews a Closed Won sales-to-post-sale handoff. Its intended value is less context hunting and fewer surprises at kickoff. No time savings or revenue impact have been measured.</a:t>
-            </a:r>
-          </a:p>
-          <a:p xmlns:a="http://schemas.openxmlformats.org/drawingml/2006/main">
-            <a:r>
-              <a:t/>
-            </a:r>
-          </a:p>
-          <a:p xmlns:a="http://schemas.openxmlformats.org/drawingml/2006/main">
-            <a:r>
-              <a:t>The five CSV objects are Account, Opportunity, Contact, OpportunityContactRole, and SalesNotes. Python selects the Closed Won opportunity, checks required fields and placeholder values, validates record relationships, and retains source evidence. The skill compares CRM fields with sales notes and produces a seven-section handoff assessment.</a:t>
-            </a:r>
-          </a:p>
-          <a:p xmlns:a="http://schemas.openxmlformats.org/drawingml/2006/main">
-            <a:r>
-              <a:t/>
-            </a:r>
-          </a:p>
-          <a:p xmlns:a="http://schemas.openxmlformats.org/drawingml/2006/main">
-            <a:r>
-              <a:t>In the conflicting-notes fixture, all structured prerequisites pass, so the validator baseline is Ready. Opportunity 0065g00003OPP001AAH, Implementation_Timeline__c, still lists the corporate pilot as 2026-10-05. Sales note a0N5g00001NOTE05AAH dated 2026-09-14 records an approved move to 2026-11-02, explicitly replacing the prior pilot start. It also says remaining rollout milestones and success-measurement deadlines require re-planning. The final assessment is Needs Review. The agent must cite both sources, keep the conflict visible, and leave resolution to people. A later note alone does not automatically establish authority.</a:t>
-            </a:r>
-          </a:p>
-          <a:p xmlns:a="http://schemas.openxmlformats.org/drawingml/2006/main">
-            <a:r>
-              <a:t/>
-            </a:r>
-          </a:p>
-          <a:p xmlns:a="http://schemas.openxmlformats.org/drawingml/2006/main">
-            <a:r>
-              <a:t>Sources within this repository: SKILL.md (Readiness Policy, Evidence Standard); scripts/analyze_handoff.py; scenarios/conflicting-notes/Opportunity.csv; scenarios/conflicting-notes/SalesNotes.csv; docs/validation-notes.md.</a:t>
-            </a:r>
-          </a:p>
-          <a:p xmlns:a="http://schemas.openxmlformats.org/drawingml/2006/main">
-            <a:r>
-              <a:t/>
-            </a:r>
-          </a:p>
-          <a:p xmlns:a="http://schemas.openxmlformats.org/drawingml/2006/main">
-            <a:r>
-              <a:t>The readiness policy is a POC business assumption: a missing sponsor, implementation timeline, or success criteria blocks the handoff. Other structured or semantic gaps require review. Malformed records and broken references are input errors, not readiness scores. v1 does not write to the CRM.</a:t>
-            </a:r>
-          </a:p>
-          <a:p xmlns:a="http://schemas.openxmlformats.org/drawingml/2006/main">
-            <a:r>
-              <a:t/>
-            </a:r>
-          </a:p>
-          <a:p xmlns:a="http://schemas.openxmlformats.org/drawingml/2006/main">
-            <a:r>
-              <a:t>All demo records are fictional. The prototype uses CSV snapshots, has no live Salesforce connection, and has no measured production impact. Production work would require agreed business rules, scoped access, data-retention controls, broader labeled evaluations, and review before any future CRM update.</a:t>
+              <a:t>Project summary for the Apollo assignment, separate from the ongoing account handoff deck.</a:t>
+            </a:r>
+          </a:p>
+          <a:p xmlns:a="http://schemas.openxmlformats.org/drawingml/2006/main">
+            <a:r>
+              <a:t>Sources: SKILL.md; README.md; examples/handoffs/terrapin-history.json; scripts/manage_handoffs.py; docs/validation-notes.md.</a:t>
+            </a:r>
+          </a:p>
+          <a:p xmlns:a="http://schemas.openxmlformats.org/drawingml/2006/main">
+            <a:r>
+              <a:t>The September 16 event transfers Samson Delilah (Sales) to Ruben Cherise (Implementation), assessed Ready under the sales profile.</a:t>
+            </a:r>
+          </a:p>
+          <a:p xmlns:a="http://schemas.openxmlformats.org/drawingml/2006/main">
+            <a:r>
+              <a:t>December 1 is a fictional future transfer from Ruben to Althea Cassidy (Customer Success), assessed Needs Review under the generic internal-transfer profile because customer training and QBR dates remain unconfirmed. It has no sales-validator baseline.</a:t>
+            </a:r>
+          </a:p>
+          <a:p xmlns:a="http://schemas.openxmlformats.org/drawingml/2006/main">
+            <a:r>
+              <a:t>The December 18 investigation-time check retains Ruben as its action owner when omitted from the second event. The current account owner is Althea. Customer contacts are distinct from these internal owners.</a:t>
+            </a:r>
+          </a:p>
+          <a:p xmlns:a="http://schemas.openxmlformats.org/drawingml/2006/main">
+            <a:r>
+              <a:t>The renderer rebuilds from saved history, preserving earlier content. It does not edit an old PowerPoint, detect CRM owner changes or write back to CRM. Manual deck edits do not update history. Python helpers use the standard library. PPTX rendering additionally needs Node.js and the @oai/artifact-tool library supplied in the demo's Codex environment.</a:t>
+            </a:r>
+          </a:p>
+          <a:p xmlns:a="http://schemas.openxmlformats.org/drawingml/2006/main">
+            <a:r>
+              <a:t>Verification: 56 Python tests passed, comprising 27 sales-validator tests and 29 history tests. The separate two-export agent review predates the ongoing deck feature and is a limited check of sales-note interpretation. No business-impact results have been measured.</a:t>
             </a:r>
           </a:p>
         </p:txBody>
@@ -560,7 +540,7 @@
   </p:cSld>
   <p:clrMap bg1="lt1" tx1="dk1" bg2="lt2" tx2="dk2" accent1="accent1" accent2="accent2" accent3="accent3" accent4="accent4" accent5="accent5" accent6="accent6" hlink="hlink" folHlink="folHlink"/>
   <p:sldLayoutIdLst>
-    <p:sldLayoutId xmlns:r="http://schemas.openxmlformats.org/officeDocument/2006/relationships" id="2147483649" r:id="R8ba87d2d2ca34f78"/>
+    <p:sldLayoutId xmlns:r="http://schemas.openxmlformats.org/officeDocument/2006/relationships" id="2147483649" r:id="R356736903b714973"/>
   </p:sldLayoutIdLst>
   <p:txStyles>
     <p:titleStyle>
@@ -1108,10 +1088,10 @@
       </p:grpSpPr>
       <p:sp>
         <p:nvSpPr>
-          <p:cNvPr id="24" name="title">
+          <p:cNvPr id="21" name="">
             <a:extLst xmlns:a="http://schemas.openxmlformats.org/drawingml/2006/main">
               <a:ext uri="{FF2B5EF4-FFF2-40B4-BE49-F238E27FC236}">
-                <a16:creationId xmlns:a16="http://schemas.microsoft.com/office/drawing/2014/main" id="{E38F6D36-15D0-49B7-95C1-FAB3049FE1FC}"/>
+                <a16:creationId xmlns:a16="http://schemas.microsoft.com/office/drawing/2014/main" id="{E94168F1-BF24-4294-940D-9157C49F2B80}"/>
               </a:ext>
             </a:extLst>
           </p:cNvPr>
@@ -1122,8 +1102,8 @@
         </p:nvSpPr>
         <p:spPr>
           <a:xfrm xmlns:a="http://schemas.openxmlformats.org/drawingml/2006/main">
-            <a:off x="552450" y="342900"/>
-            <a:ext cx="11087100" cy="619125"/>
+            <a:off x="609600" y="323850"/>
+            <a:ext cx="10953750" cy="609600"/>
           </a:xfrm>
           <a:prstGeom xmlns:a="http://schemas.openxmlformats.org/drawingml/2006/main" prst="rect">
             <a:avLst/>
@@ -1134,13 +1114,13 @@
           </a:ln>
         </p:spPr>
         <p:txBody>
-          <a:bodyPr xmlns:a="http://schemas.openxmlformats.org/drawingml/2006/main">
+          <a:bodyPr xmlns:a="http://schemas.openxmlformats.org/drawingml/2006/main" anchor="ctr">
             <a:noAutofit/>
           </a:bodyPr>
           <a:lstStyle xmlns:a="http://schemas.openxmlformats.org/drawingml/2006/main"/>
           <a:p xmlns:a="http://schemas.openxmlformats.org/drawingml/2006/main">
             <a:pPr>
-              <a:defRPr sz="3600" b="1">
+              <a:defRPr sz="3675" b="1">
                 <a:solidFill>
                   <a:srgbClr val="172D42"/>
                 </a:solidFill>
@@ -1150,7 +1130,7 @@
               </a:defRPr>
             </a:pPr>
             <a:r>
-              <a:rPr sz="3600" b="1">
+              <a:rPr sz="3675" b="1">
                 <a:solidFill>
                   <a:srgbClr val="172D42"/>
                 </a:solidFill>
@@ -1165,10 +1145,10 @@
       </p:sp>
       <p:sp>
         <p:nvSpPr>
-          <p:cNvPr id="2" name="problem">
+          <p:cNvPr id="2" name="">
             <a:extLst xmlns:a="http://schemas.openxmlformats.org/drawingml/2006/main">
               <a:ext uri="{FF2B5EF4-FFF2-40B4-BE49-F238E27FC236}">
-                <a16:creationId xmlns:a16="http://schemas.microsoft.com/office/drawing/2014/main" id="{ECC97863-A017-4B15-8896-9DE6C289A758}"/>
+                <a16:creationId xmlns:a16="http://schemas.microsoft.com/office/drawing/2014/main" id="{81EB2083-B34A-46A5-BA3F-412EE1051DC7}"/>
               </a:ext>
             </a:extLst>
           </p:cNvPr>
@@ -1179,8 +1159,8 @@
         </p:nvSpPr>
         <p:spPr>
           <a:xfrm xmlns:a="http://schemas.openxmlformats.org/drawingml/2006/main">
-            <a:off x="571500" y="1047750"/>
-            <a:ext cx="10668000" cy="381000"/>
+            <a:off x="628650" y="1076325"/>
+            <a:ext cx="10934700" cy="447675"/>
           </a:xfrm>
           <a:prstGeom xmlns:a="http://schemas.openxmlformats.org/drawingml/2006/main" prst="rect">
             <a:avLst/>
@@ -1191,13 +1171,13 @@
           </a:ln>
         </p:spPr>
         <p:txBody>
-          <a:bodyPr xmlns:a="http://schemas.openxmlformats.org/drawingml/2006/main">
+          <a:bodyPr xmlns:a="http://schemas.openxmlformats.org/drawingml/2006/main" anchor="ctr">
             <a:noAutofit/>
           </a:bodyPr>
           <a:lstStyle xmlns:a="http://schemas.openxmlformats.org/drawingml/2006/main"/>
           <a:p xmlns:a="http://schemas.openxmlformats.org/drawingml/2006/main">
             <a:pPr>
-              <a:defRPr sz="2100" b="0">
+              <a:defRPr sz="2175" b="0">
                 <a:solidFill>
                   <a:srgbClr val="172D42"/>
                 </a:solidFill>
@@ -1207,7 +1187,7 @@
               </a:defRPr>
             </a:pPr>
             <a:r>
-              <a:rPr sz="2100" b="0">
+              <a:rPr sz="2175" b="0">
                 <a:solidFill>
                   <a:srgbClr val="172D42"/>
                 </a:solidFill>
@@ -1215,17 +1195,17 @@
                 <a:ea typeface="Arial"/>
                 <a:cs typeface="Arial"/>
               </a:rPr>
-              <a:t>Closed Won fields can miss promises buried in sales notes.</a:t>
-            </a:r>
-          </a:p>
-        </p:txBody>
-      </p:sp>
-      <p:sp>
-        <p:nvSpPr>
-          <p:cNvPr id="3" name="value">
+              <a:t>One account deck that grows with each handoff.</a:t>
+            </a:r>
+          </a:p>
+        </p:txBody>
+      </p:sp>
+      <p:sp>
+        <p:nvSpPr>
+          <p:cNvPr id="3" name="">
             <a:extLst xmlns:a="http://schemas.openxmlformats.org/drawingml/2006/main">
               <a:ext uri="{FF2B5EF4-FFF2-40B4-BE49-F238E27FC236}">
-                <a16:creationId xmlns:a16="http://schemas.microsoft.com/office/drawing/2014/main" id="{3D7714D7-A62A-4815-8E8A-D3549C2D78CD}"/>
+                <a16:creationId xmlns:a16="http://schemas.microsoft.com/office/drawing/2014/main" id="{D2DC84CC-1304-42DD-A199-A348A8B95E04}"/>
               </a:ext>
             </a:extLst>
           </p:cNvPr>
@@ -1236,8 +1216,8 @@
         </p:nvSpPr>
         <p:spPr>
           <a:xfrm xmlns:a="http://schemas.openxmlformats.org/drawingml/2006/main">
-            <a:off x="571500" y="1495425"/>
-            <a:ext cx="10858500" cy="381000"/>
+            <a:off x="628650" y="1562100"/>
+            <a:ext cx="10934700" cy="409575"/>
           </a:xfrm>
           <a:prstGeom xmlns:a="http://schemas.openxmlformats.org/drawingml/2006/main" prst="rect">
             <a:avLst/>
@@ -1248,7 +1228,7 @@
           </a:ln>
         </p:spPr>
         <p:txBody>
-          <a:bodyPr xmlns:a="http://schemas.openxmlformats.org/drawingml/2006/main">
+          <a:bodyPr xmlns:a="http://schemas.openxmlformats.org/drawingml/2006/main" anchor="ctr">
             <a:noAutofit/>
           </a:bodyPr>
           <a:lstStyle xmlns:a="http://schemas.openxmlformats.org/drawingml/2006/main"/>
@@ -1272,17 +1252,17 @@
                 <a:ea typeface="Arial"/>
                 <a:cs typeface="Arial"/>
               </a:rPr>
-              <a:t>The skill helps post-sale teams find missing decisions before kickoff.</a:t>
-            </a:r>
-          </a:p>
-        </p:txBody>
-      </p:sp>
-      <p:sp>
-        <p:nvSpPr>
-          <p:cNvPr id="4" name="flow-0">
+              <a:t>The aim: less handoff rework and fewer dropped commitments.</a:t>
+            </a:r>
+          </a:p>
+        </p:txBody>
+      </p:sp>
+      <p:sp>
+        <p:nvSpPr>
+          <p:cNvPr id="4" name="">
             <a:extLst xmlns:a="http://schemas.openxmlformats.org/drawingml/2006/main">
               <a:ext uri="{FF2B5EF4-FFF2-40B4-BE49-F238E27FC236}">
-                <a16:creationId xmlns:a16="http://schemas.microsoft.com/office/drawing/2014/main" id="{164D4A5F-2671-49BF-BFB5-D93E90FA6B64}"/>
+                <a16:creationId xmlns:a16="http://schemas.microsoft.com/office/drawing/2014/main" id="{55D9AD1D-3D42-4772-AAA1-5E99643A4285}"/>
               </a:ext>
             </a:extLst>
           </p:cNvPr>
@@ -1293,8 +1273,8 @@
         </p:nvSpPr>
         <p:spPr>
           <a:xfrm xmlns:a="http://schemas.openxmlformats.org/drawingml/2006/main">
-            <a:off x="571500" y="2390775"/>
-            <a:ext cx="2200275" cy="409575"/>
+            <a:off x="628650" y="2505075"/>
+            <a:ext cx="2714625" cy="371475"/>
           </a:xfrm>
           <a:prstGeom xmlns:a="http://schemas.openxmlformats.org/drawingml/2006/main" prst="rect">
             <a:avLst/>
@@ -1305,13 +1285,13 @@
           </a:ln>
         </p:spPr>
         <p:txBody>
-          <a:bodyPr xmlns:a="http://schemas.openxmlformats.org/drawingml/2006/main">
+          <a:bodyPr xmlns:a="http://schemas.openxmlformats.org/drawingml/2006/main" anchor="ctr">
             <a:noAutofit/>
           </a:bodyPr>
           <a:lstStyle xmlns:a="http://schemas.openxmlformats.org/drawingml/2006/main"/>
           <a:p xmlns:a="http://schemas.openxmlformats.org/drawingml/2006/main">
             <a:pPr>
-              <a:defRPr sz="2025" b="1">
+              <a:defRPr sz="1913" b="1">
                 <a:solidFill>
                   <a:srgbClr val="172D42"/>
                 </a:solidFill>
@@ -1321,7 +1301,7 @@
               </a:defRPr>
             </a:pPr>
             <a:r>
-              <a:rPr sz="2025" b="1">
+              <a:rPr sz="1913" b="1">
                 <a:solidFill>
                   <a:srgbClr val="172D42"/>
                 </a:solidFill>
@@ -1329,17 +1309,17 @@
                 <a:ea typeface="Arial"/>
                 <a:cs typeface="Arial"/>
               </a:rPr>
-              <a:t>Five CSVs</a:t>
-            </a:r>
-          </a:p>
-        </p:txBody>
-      </p:sp>
-      <p:sp>
-        <p:nvSpPr>
-          <p:cNvPr id="5" name="detail-0">
+              <a:t>Transfer evidence</a:t>
+            </a:r>
+          </a:p>
+        </p:txBody>
+      </p:sp>
+      <p:sp>
+        <p:nvSpPr>
+          <p:cNvPr id="5" name="">
             <a:extLst xmlns:a="http://schemas.openxmlformats.org/drawingml/2006/main">
               <a:ext uri="{FF2B5EF4-FFF2-40B4-BE49-F238E27FC236}">
-                <a16:creationId xmlns:a16="http://schemas.microsoft.com/office/drawing/2014/main" id="{982638D1-28D8-4E30-8E23-3F792D1A08B7}"/>
+                <a16:creationId xmlns:a16="http://schemas.microsoft.com/office/drawing/2014/main" id="{0ADCC359-DD35-49C5-8E99-F2E2DAD51806}"/>
               </a:ext>
             </a:extLst>
           </p:cNvPr>
@@ -1350,8 +1330,8 @@
         </p:nvSpPr>
         <p:spPr>
           <a:xfrm xmlns:a="http://schemas.openxmlformats.org/drawingml/2006/main">
-            <a:off x="571500" y="2876550"/>
-            <a:ext cx="2305050" cy="685800"/>
+            <a:off x="628650" y="2943225"/>
+            <a:ext cx="2714625" cy="609600"/>
           </a:xfrm>
           <a:prstGeom xmlns:a="http://schemas.openxmlformats.org/drawingml/2006/main" prst="rect">
             <a:avLst/>
@@ -1362,13 +1342,13 @@
           </a:ln>
         </p:spPr>
         <p:txBody>
-          <a:bodyPr xmlns:a="http://schemas.openxmlformats.org/drawingml/2006/main">
+          <a:bodyPr xmlns:a="http://schemas.openxmlformats.org/drawingml/2006/main" anchor="ctr">
             <a:noAutofit/>
           </a:bodyPr>
           <a:lstStyle xmlns:a="http://schemas.openxmlformats.org/drawingml/2006/main"/>
           <a:p xmlns:a="http://schemas.openxmlformats.org/drawingml/2006/main">
             <a:pPr>
-              <a:defRPr sz="1800" b="0">
+              <a:defRPr sz="1650" b="0">
                 <a:solidFill>
                   <a:srgbClr val="53606A"/>
                 </a:solidFill>
@@ -1378,7 +1358,7 @@
               </a:defRPr>
             </a:pPr>
             <a:r>
-              <a:rPr sz="1800" b="0">
+              <a:rPr sz="1650" b="0">
                 <a:solidFill>
                   <a:srgbClr val="53606A"/>
                 </a:solidFill>
@@ -1386,12 +1366,12 @@
                 <a:ea typeface="Arial"/>
                 <a:cs typeface="Arial"/>
               </a:rPr>
-              <a:t>Salesforce-style</a:t>
+              <a:t>Five sales CSVs, owner</a:t>
             </a:r>
           </a:p>
           <a:p xmlns:a="http://schemas.openxmlformats.org/drawingml/2006/main">
             <a:pPr>
-              <a:defRPr sz="1800" b="0">
+              <a:defRPr sz="1650" b="0">
                 <a:solidFill>
                   <a:srgbClr val="53606A"/>
                 </a:solidFill>
@@ -1401,7 +1381,7 @@
               </a:defRPr>
             </a:pPr>
             <a:r>
-              <a:rPr sz="1800" b="0">
+              <a:rPr sz="1650" b="0">
                 <a:solidFill>
                   <a:srgbClr val="53606A"/>
                 </a:solidFill>
@@ -1409,17 +1389,17 @@
                 <a:ea typeface="Arial"/>
                 <a:cs typeface="Arial"/>
               </a:rPr>
-              <a:t>mock records</a:t>
-            </a:r>
-          </a:p>
-        </p:txBody>
-      </p:sp>
-      <p:sp>
-        <p:nvSpPr>
-          <p:cNvPr id="6" name="flow-1">
+              <a:t>changes and notes</a:t>
+            </a:r>
+          </a:p>
+        </p:txBody>
+      </p:sp>
+      <p:sp>
+        <p:nvSpPr>
+          <p:cNvPr id="6" name="">
             <a:extLst xmlns:a="http://schemas.openxmlformats.org/drawingml/2006/main">
               <a:ext uri="{FF2B5EF4-FFF2-40B4-BE49-F238E27FC236}">
-                <a16:creationId xmlns:a16="http://schemas.microsoft.com/office/drawing/2014/main" id="{C0FF32AB-FE17-403B-BD51-07070C59BB16}"/>
+                <a16:creationId xmlns:a16="http://schemas.microsoft.com/office/drawing/2014/main" id="{022022B1-658C-45B8-AEB1-2D9227986C6C}"/>
               </a:ext>
             </a:extLst>
           </p:cNvPr>
@@ -1430,8 +1410,8 @@
         </p:nvSpPr>
         <p:spPr>
           <a:xfrm xmlns:a="http://schemas.openxmlformats.org/drawingml/2006/main">
-            <a:off x="3514725" y="2390775"/>
-            <a:ext cx="2200275" cy="409575"/>
+            <a:off x="3619500" y="2505075"/>
+            <a:ext cx="2714625" cy="371475"/>
           </a:xfrm>
           <a:prstGeom xmlns:a="http://schemas.openxmlformats.org/drawingml/2006/main" prst="rect">
             <a:avLst/>
@@ -1442,13 +1422,13 @@
           </a:ln>
         </p:spPr>
         <p:txBody>
-          <a:bodyPr xmlns:a="http://schemas.openxmlformats.org/drawingml/2006/main">
+          <a:bodyPr xmlns:a="http://schemas.openxmlformats.org/drawingml/2006/main" anchor="ctr">
             <a:noAutofit/>
           </a:bodyPr>
           <a:lstStyle xmlns:a="http://schemas.openxmlformats.org/drawingml/2006/main"/>
           <a:p xmlns:a="http://schemas.openxmlformats.org/drawingml/2006/main">
             <a:pPr>
-              <a:defRPr sz="2025" b="1">
+              <a:defRPr sz="1913" b="1">
                 <a:solidFill>
                   <a:srgbClr val="172D42"/>
                 </a:solidFill>
@@ -1458,7 +1438,7 @@
               </a:defRPr>
             </a:pPr>
             <a:r>
-              <a:rPr sz="2025" b="1">
+              <a:rPr sz="1913" b="1">
                 <a:solidFill>
                   <a:srgbClr val="172D42"/>
                 </a:solidFill>
@@ -1466,17 +1446,17 @@
                 <a:ea typeface="Arial"/>
                 <a:cs typeface="Arial"/>
               </a:rPr>
-              <a:t>Python checks</a:t>
-            </a:r>
-          </a:p>
-        </p:txBody>
-      </p:sp>
-      <p:sp>
-        <p:nvSpPr>
-          <p:cNvPr id="7" name="detail-1">
+              <a:t>Python + skill</a:t>
+            </a:r>
+          </a:p>
+        </p:txBody>
+      </p:sp>
+      <p:sp>
+        <p:nvSpPr>
+          <p:cNvPr id="7" name="">
             <a:extLst xmlns:a="http://schemas.openxmlformats.org/drawingml/2006/main">
               <a:ext uri="{FF2B5EF4-FFF2-40B4-BE49-F238E27FC236}">
-                <a16:creationId xmlns:a16="http://schemas.microsoft.com/office/drawing/2014/main" id="{E01F61AD-181D-432E-BABF-F451B7B467AB}"/>
+                <a16:creationId xmlns:a16="http://schemas.microsoft.com/office/drawing/2014/main" id="{60878785-2C2E-478C-AB2C-D9699D53757B}"/>
               </a:ext>
             </a:extLst>
           </p:cNvPr>
@@ -1487,8 +1467,8 @@
         </p:nvSpPr>
         <p:spPr>
           <a:xfrm xmlns:a="http://schemas.openxmlformats.org/drawingml/2006/main">
-            <a:off x="3514725" y="2876550"/>
-            <a:ext cx="2305050" cy="685800"/>
+            <a:off x="3619500" y="2943225"/>
+            <a:ext cx="2714625" cy="609600"/>
           </a:xfrm>
           <a:prstGeom xmlns:a="http://schemas.openxmlformats.org/drawingml/2006/main" prst="rect">
             <a:avLst/>
@@ -1499,13 +1479,13 @@
           </a:ln>
         </p:spPr>
         <p:txBody>
-          <a:bodyPr xmlns:a="http://schemas.openxmlformats.org/drawingml/2006/main">
+          <a:bodyPr xmlns:a="http://schemas.openxmlformats.org/drawingml/2006/main" anchor="ctr">
             <a:noAutofit/>
           </a:bodyPr>
           <a:lstStyle xmlns:a="http://schemas.openxmlformats.org/drawingml/2006/main"/>
           <a:p xmlns:a="http://schemas.openxmlformats.org/drawingml/2006/main">
             <a:pPr>
-              <a:defRPr sz="1800" b="0">
+              <a:defRPr sz="1650" b="0">
                 <a:solidFill>
                   <a:srgbClr val="53606A"/>
                 </a:solidFill>
@@ -1515,7 +1495,7 @@
               </a:defRPr>
             </a:pPr>
             <a:r>
-              <a:rPr sz="1800" b="0">
+              <a:rPr sz="1650" b="0">
                 <a:solidFill>
                   <a:srgbClr val="53606A"/>
                 </a:solidFill>
@@ -1523,12 +1503,12 @@
                 <a:ea typeface="Arial"/>
                 <a:cs typeface="Arial"/>
               </a:rPr>
-              <a:t>Required fields</a:t>
+              <a:t>Check records and</a:t>
             </a:r>
           </a:p>
           <a:p xmlns:a="http://schemas.openxmlformats.org/drawingml/2006/main">
             <a:pPr>
-              <a:defRPr sz="1800" b="0">
+              <a:defRPr sz="1650" b="0">
                 <a:solidFill>
                   <a:srgbClr val="53606A"/>
                 </a:solidFill>
@@ -1538,7 +1518,7 @@
               </a:defRPr>
             </a:pPr>
             <a:r>
-              <a:rPr sz="1800" b="0">
+              <a:rPr sz="1650" b="0">
                 <a:solidFill>
                   <a:srgbClr val="53606A"/>
                 </a:solidFill>
@@ -1546,17 +1526,17 @@
                 <a:ea typeface="Arial"/>
                 <a:cs typeface="Arial"/>
               </a:rPr>
-              <a:t>and record links</a:t>
-            </a:r>
-          </a:p>
-        </p:txBody>
-      </p:sp>
-      <p:sp>
-        <p:nvSpPr>
-          <p:cNvPr id="8" name="flow-2">
+              <a:t>assess the evidence</a:t>
+            </a:r>
+          </a:p>
+        </p:txBody>
+      </p:sp>
+      <p:sp>
+        <p:nvSpPr>
+          <p:cNvPr id="8" name="">
             <a:extLst xmlns:a="http://schemas.openxmlformats.org/drawingml/2006/main">
               <a:ext uri="{FF2B5EF4-FFF2-40B4-BE49-F238E27FC236}">
-                <a16:creationId xmlns:a16="http://schemas.microsoft.com/office/drawing/2014/main" id="{9E0E87E5-DB26-4E0E-B6CF-6A5D508E74DA}"/>
+                <a16:creationId xmlns:a16="http://schemas.microsoft.com/office/drawing/2014/main" id="{34F65BED-CAD0-404F-9634-5562F8826B68}"/>
               </a:ext>
             </a:extLst>
           </p:cNvPr>
@@ -1567,8 +1547,8 @@
         </p:nvSpPr>
         <p:spPr>
           <a:xfrm xmlns:a="http://schemas.openxmlformats.org/drawingml/2006/main">
-            <a:off x="6457950" y="2390775"/>
-            <a:ext cx="2200275" cy="409575"/>
+            <a:off x="6610350" y="2505075"/>
+            <a:ext cx="2714625" cy="371475"/>
           </a:xfrm>
           <a:prstGeom xmlns:a="http://schemas.openxmlformats.org/drawingml/2006/main" prst="rect">
             <a:avLst/>
@@ -1579,13 +1559,13 @@
           </a:ln>
         </p:spPr>
         <p:txBody>
-          <a:bodyPr xmlns:a="http://schemas.openxmlformats.org/drawingml/2006/main">
+          <a:bodyPr xmlns:a="http://schemas.openxmlformats.org/drawingml/2006/main" anchor="ctr">
             <a:noAutofit/>
           </a:bodyPr>
           <a:lstStyle xmlns:a="http://schemas.openxmlformats.org/drawingml/2006/main"/>
           <a:p xmlns:a="http://schemas.openxmlformats.org/drawingml/2006/main">
             <a:pPr>
-              <a:defRPr sz="2025" b="1">
+              <a:defRPr sz="1913" b="1">
                 <a:solidFill>
                   <a:srgbClr val="172D42"/>
                 </a:solidFill>
@@ -1595,7 +1575,7 @@
               </a:defRPr>
             </a:pPr>
             <a:r>
-              <a:rPr sz="2025" b="1">
+              <a:rPr sz="1913" b="1">
                 <a:solidFill>
                   <a:srgbClr val="172D42"/>
                 </a:solidFill>
@@ -1603,17 +1583,17 @@
                 <a:ea typeface="Arial"/>
                 <a:cs typeface="Arial"/>
               </a:rPr>
-              <a:t>Agent review</a:t>
-            </a:r>
-          </a:p>
-        </p:txBody>
-      </p:sp>
-      <p:sp>
-        <p:nvSpPr>
-          <p:cNvPr id="9" name="detail-2">
+              <a:t>Saved history</a:t>
+            </a:r>
+          </a:p>
+        </p:txBody>
+      </p:sp>
+      <p:sp>
+        <p:nvSpPr>
+          <p:cNvPr id="9" name="">
             <a:extLst xmlns:a="http://schemas.openxmlformats.org/drawingml/2006/main">
               <a:ext uri="{FF2B5EF4-FFF2-40B4-BE49-F238E27FC236}">
-                <a16:creationId xmlns:a16="http://schemas.microsoft.com/office/drawing/2014/main" id="{F44AA6E6-0D17-43C5-86FF-E4A869606892}"/>
+                <a16:creationId xmlns:a16="http://schemas.microsoft.com/office/drawing/2014/main" id="{458A3F19-ADAB-4587-9CC5-91EE33100480}"/>
               </a:ext>
             </a:extLst>
           </p:cNvPr>
@@ -1624,8 +1604,8 @@
         </p:nvSpPr>
         <p:spPr>
           <a:xfrm xmlns:a="http://schemas.openxmlformats.org/drawingml/2006/main">
-            <a:off x="6457950" y="2876550"/>
-            <a:ext cx="2305050" cy="685800"/>
+            <a:off x="6610350" y="2943225"/>
+            <a:ext cx="2714625" cy="609600"/>
           </a:xfrm>
           <a:prstGeom xmlns:a="http://schemas.openxmlformats.org/drawingml/2006/main" prst="rect">
             <a:avLst/>
@@ -1636,13 +1616,13 @@
           </a:ln>
         </p:spPr>
         <p:txBody>
-          <a:bodyPr xmlns:a="http://schemas.openxmlformats.org/drawingml/2006/main">
+          <a:bodyPr xmlns:a="http://schemas.openxmlformats.org/drawingml/2006/main" anchor="ctr">
             <a:noAutofit/>
           </a:bodyPr>
           <a:lstStyle xmlns:a="http://schemas.openxmlformats.org/drawingml/2006/main"/>
           <a:p xmlns:a="http://schemas.openxmlformats.org/drawingml/2006/main">
             <a:pPr>
-              <a:defRPr sz="1800" b="0">
+              <a:defRPr sz="1650" b="0">
                 <a:solidFill>
                   <a:srgbClr val="53606A"/>
                 </a:solidFill>
@@ -1652,7 +1632,7 @@
               </a:defRPr>
             </a:pPr>
             <a:r>
-              <a:rPr sz="1800" b="0">
+              <a:rPr sz="1650" b="0">
                 <a:solidFill>
                   <a:srgbClr val="53606A"/>
                 </a:solidFill>
@@ -1660,12 +1640,12 @@
                 <a:ea typeface="Arial"/>
                 <a:cs typeface="Arial"/>
               </a:rPr>
-              <a:t>Compare CRM</a:t>
+              <a:t>Keep dated facts</a:t>
             </a:r>
           </a:p>
           <a:p xmlns:a="http://schemas.openxmlformats.org/drawingml/2006/main">
             <a:pPr>
-              <a:defRPr sz="1800" b="0">
+              <a:defRPr sz="1650" b="0">
                 <a:solidFill>
                   <a:srgbClr val="53606A"/>
                 </a:solidFill>
@@ -1675,7 +1655,7 @@
               </a:defRPr>
             </a:pPr>
             <a:r>
-              <a:rPr sz="1800" b="0">
+              <a:rPr sz="1650" b="0">
                 <a:solidFill>
                   <a:srgbClr val="53606A"/>
                 </a:solidFill>
@@ -1683,17 +1663,17 @@
                 <a:ea typeface="Arial"/>
                 <a:cs typeface="Arial"/>
               </a:rPr>
-              <a:t>with sales notes</a:t>
-            </a:r>
-          </a:p>
-        </p:txBody>
-      </p:sp>
-      <p:sp>
-        <p:nvSpPr>
-          <p:cNvPr id="10" name="flow-3">
+              <a:t>and unfinished work</a:t>
+            </a:r>
+          </a:p>
+        </p:txBody>
+      </p:sp>
+      <p:sp>
+        <p:nvSpPr>
+          <p:cNvPr id="10" name="">
             <a:extLst xmlns:a="http://schemas.openxmlformats.org/drawingml/2006/main">
               <a:ext uri="{FF2B5EF4-FFF2-40B4-BE49-F238E27FC236}">
-                <a16:creationId xmlns:a16="http://schemas.microsoft.com/office/drawing/2014/main" id="{AA7D33B8-61EC-4696-BF33-0C24EE399550}"/>
+                <a16:creationId xmlns:a16="http://schemas.microsoft.com/office/drawing/2014/main" id="{7B3BF414-39AB-4713-BBEE-AE40F55957C0}"/>
               </a:ext>
             </a:extLst>
           </p:cNvPr>
@@ -1704,8 +1684,8 @@
         </p:nvSpPr>
         <p:spPr>
           <a:xfrm xmlns:a="http://schemas.openxmlformats.org/drawingml/2006/main">
-            <a:off x="9401175" y="2390775"/>
-            <a:ext cx="2200275" cy="409575"/>
+            <a:off x="9601200" y="2505075"/>
+            <a:ext cx="2066925" cy="371475"/>
           </a:xfrm>
           <a:prstGeom xmlns:a="http://schemas.openxmlformats.org/drawingml/2006/main" prst="rect">
             <a:avLst/>
@@ -1716,13 +1696,13 @@
           </a:ln>
         </p:spPr>
         <p:txBody>
-          <a:bodyPr xmlns:a="http://schemas.openxmlformats.org/drawingml/2006/main">
+          <a:bodyPr xmlns:a="http://schemas.openxmlformats.org/drawingml/2006/main" anchor="ctr">
             <a:noAutofit/>
           </a:bodyPr>
           <a:lstStyle xmlns:a="http://schemas.openxmlformats.org/drawingml/2006/main"/>
           <a:p xmlns:a="http://schemas.openxmlformats.org/drawingml/2006/main">
             <a:pPr>
-              <a:defRPr sz="2025" b="1">
+              <a:defRPr sz="1913" b="1">
                 <a:solidFill>
                   <a:srgbClr val="172D42"/>
                 </a:solidFill>
@@ -1732,7 +1712,7 @@
               </a:defRPr>
             </a:pPr>
             <a:r>
-              <a:rPr sz="2025" b="1">
+              <a:rPr sz="1913" b="1">
                 <a:solidFill>
                   <a:srgbClr val="172D42"/>
                 </a:solidFill>
@@ -1740,17 +1720,17 @@
                 <a:ea typeface="Arial"/>
                 <a:cs typeface="Arial"/>
               </a:rPr>
-              <a:t>Handoff brief</a:t>
-            </a:r>
-          </a:p>
-        </p:txBody>
-      </p:sp>
-      <p:sp>
-        <p:nvSpPr>
-          <p:cNvPr id="11" name="detail-3">
+              <a:t>Account deck</a:t>
+            </a:r>
+          </a:p>
+        </p:txBody>
+      </p:sp>
+      <p:sp>
+        <p:nvSpPr>
+          <p:cNvPr id="11" name="">
             <a:extLst xmlns:a="http://schemas.openxmlformats.org/drawingml/2006/main">
               <a:ext uri="{FF2B5EF4-FFF2-40B4-BE49-F238E27FC236}">
-                <a16:creationId xmlns:a16="http://schemas.microsoft.com/office/drawing/2014/main" id="{A1FD9088-BFB4-4997-A9E3-883BD26E082E}"/>
+                <a16:creationId xmlns:a16="http://schemas.microsoft.com/office/drawing/2014/main" id="{5FD1EE95-2651-4A40-AA65-FBD8781C1A1C}"/>
               </a:ext>
             </a:extLst>
           </p:cNvPr>
@@ -1761,8 +1741,8 @@
         </p:nvSpPr>
         <p:spPr>
           <a:xfrm xmlns:a="http://schemas.openxmlformats.org/drawingml/2006/main">
-            <a:off x="9401175" y="2876550"/>
-            <a:ext cx="2305050" cy="685800"/>
+            <a:off x="9601200" y="2943225"/>
+            <a:ext cx="2066925" cy="609600"/>
           </a:xfrm>
           <a:prstGeom xmlns:a="http://schemas.openxmlformats.org/drawingml/2006/main" prst="rect">
             <a:avLst/>
@@ -1773,13 +1753,13 @@
           </a:ln>
         </p:spPr>
         <p:txBody>
-          <a:bodyPr xmlns:a="http://schemas.openxmlformats.org/drawingml/2006/main">
+          <a:bodyPr xmlns:a="http://schemas.openxmlformats.org/drawingml/2006/main" anchor="ctr">
             <a:noAutofit/>
           </a:bodyPr>
           <a:lstStyle xmlns:a="http://schemas.openxmlformats.org/drawingml/2006/main"/>
           <a:p xmlns:a="http://schemas.openxmlformats.org/drawingml/2006/main">
             <a:pPr>
-              <a:defRPr sz="1800" b="0">
+              <a:defRPr sz="1650" b="0">
                 <a:solidFill>
                   <a:srgbClr val="53606A"/>
                 </a:solidFill>
@@ -1789,7 +1769,7 @@
               </a:defRPr>
             </a:pPr>
             <a:r>
-              <a:rPr sz="1800" b="0">
+              <a:rPr sz="1650" b="0">
                 <a:solidFill>
                   <a:srgbClr val="53606A"/>
                 </a:solidFill>
@@ -1797,12 +1777,12 @@
                 <a:ea typeface="Arial"/>
                 <a:cs typeface="Arial"/>
               </a:rPr>
-              <a:t>Readiness, sources</a:t>
+              <a:t>Latest view and</a:t>
             </a:r>
           </a:p>
           <a:p xmlns:a="http://schemas.openxmlformats.org/drawingml/2006/main">
             <a:pPr>
-              <a:defRPr sz="1800" b="0">
+              <a:defRPr sz="1650" b="0">
                 <a:solidFill>
                   <a:srgbClr val="53606A"/>
                 </a:solidFill>
@@ -1812,7 +1792,7 @@
               </a:defRPr>
             </a:pPr>
             <a:r>
-              <a:rPr sz="1800" b="0">
+              <a:rPr sz="1650" b="0">
                 <a:solidFill>
                   <a:srgbClr val="53606A"/>
                 </a:solidFill>
@@ -1820,92 +1800,17 @@
                 <a:ea typeface="Arial"/>
                 <a:cs typeface="Arial"/>
               </a:rPr>
-              <a:t>and open questions</a:t>
-            </a:r>
-          </a:p>
-        </p:txBody>
-      </p:sp>
-      <p:cxnSp>
-        <p:nvCxnSpPr>
-          <p:cNvPr id="35" name=""/>
-          <p:cNvCxnSpPr>
-            <a:stCxn xmlns:a="http://schemas.openxmlformats.org/drawingml/2006/main" id="4" idx="3"/>
-            <a:endCxn xmlns:a="http://schemas.openxmlformats.org/drawingml/2006/main" id="6" idx="1"/>
-          </p:cNvCxnSpPr>
-          <p:nvPr/>
-        </p:nvCxnSpPr>
-        <p:spPr>
-          <a:xfrm xmlns:a="http://schemas.openxmlformats.org/drawingml/2006/main">
-            <a:off x="2771775" y="2595563"/>
-            <a:ext cx="742950" cy="0"/>
-          </a:xfrm>
-          <a:prstGeom xmlns:a="http://schemas.openxmlformats.org/drawingml/2006/main" prst="straightConnector1">
-            <a:avLst/>
-          </a:prstGeom>
-          <a:ln xmlns:a="http://schemas.openxmlformats.org/drawingml/2006/main" w="19050">
-            <a:solidFill>
-              <a:srgbClr val="A63646"/>
-            </a:solidFill>
-            <a:tailEnd type="arrow" w="med" len="med"/>
-          </a:ln>
-        </p:spPr>
-      </p:cxnSp>
-      <p:cxnSp>
-        <p:nvCxnSpPr>
-          <p:cNvPr id="36" name=""/>
-          <p:cNvCxnSpPr>
-            <a:stCxn xmlns:a="http://schemas.openxmlformats.org/drawingml/2006/main" id="6" idx="3"/>
-            <a:endCxn xmlns:a="http://schemas.openxmlformats.org/drawingml/2006/main" id="8" idx="1"/>
-          </p:cNvCxnSpPr>
-          <p:nvPr/>
-        </p:nvCxnSpPr>
-        <p:spPr>
-          <a:xfrm xmlns:a="http://schemas.openxmlformats.org/drawingml/2006/main">
-            <a:off x="5715000" y="2595563"/>
-            <a:ext cx="742950" cy="0"/>
-          </a:xfrm>
-          <a:prstGeom xmlns:a="http://schemas.openxmlformats.org/drawingml/2006/main" prst="straightConnector1">
-            <a:avLst/>
-          </a:prstGeom>
-          <a:ln xmlns:a="http://schemas.openxmlformats.org/drawingml/2006/main" w="19050">
-            <a:solidFill>
-              <a:srgbClr val="A63646"/>
-            </a:solidFill>
-            <a:tailEnd type="arrow" w="med" len="med"/>
-          </a:ln>
-        </p:spPr>
-      </p:cxnSp>
-      <p:cxnSp>
-        <p:nvCxnSpPr>
-          <p:cNvPr id="37" name=""/>
-          <p:cNvCxnSpPr>
-            <a:stCxn xmlns:a="http://schemas.openxmlformats.org/drawingml/2006/main" id="8" idx="3"/>
-            <a:endCxn xmlns:a="http://schemas.openxmlformats.org/drawingml/2006/main" id="10" idx="1"/>
-          </p:cNvCxnSpPr>
-          <p:nvPr/>
-        </p:nvCxnSpPr>
-        <p:spPr>
-          <a:xfrm xmlns:a="http://schemas.openxmlformats.org/drawingml/2006/main">
-            <a:off x="8658225" y="2595563"/>
-            <a:ext cx="742950" cy="0"/>
-          </a:xfrm>
-          <a:prstGeom xmlns:a="http://schemas.openxmlformats.org/drawingml/2006/main" prst="straightConnector1">
-            <a:avLst/>
-          </a:prstGeom>
-          <a:ln xmlns:a="http://schemas.openxmlformats.org/drawingml/2006/main" w="19050">
-            <a:solidFill>
-              <a:srgbClr val="A63646"/>
-            </a:solidFill>
-            <a:tailEnd type="arrow" w="med" len="med"/>
-          </a:ln>
-        </p:spPr>
-      </p:cxnSp>
-      <p:sp>
-        <p:nvSpPr>
-          <p:cNvPr id="15" name="demo-label">
+              <a:t>dated handoffs</a:t>
+            </a:r>
+          </a:p>
+        </p:txBody>
+      </p:sp>
+      <p:sp>
+        <p:nvSpPr>
+          <p:cNvPr id="12" name="">
             <a:extLst xmlns:a="http://schemas.openxmlformats.org/drawingml/2006/main">
               <a:ext uri="{FF2B5EF4-FFF2-40B4-BE49-F238E27FC236}">
-                <a16:creationId xmlns:a16="http://schemas.microsoft.com/office/drawing/2014/main" id="{51705D8F-B390-44D9-8C1B-B55FD2738B95}"/>
+                <a16:creationId xmlns:a16="http://schemas.microsoft.com/office/drawing/2014/main" id="{62552A2C-F86F-42E0-92E3-39388FC25E4E}"/>
               </a:ext>
             </a:extLst>
           </p:cNvPr>
@@ -1916,8 +1821,8 @@
         </p:nvSpPr>
         <p:spPr>
           <a:xfrm xmlns:a="http://schemas.openxmlformats.org/drawingml/2006/main">
-            <a:off x="571500" y="4010025"/>
-            <a:ext cx="7429500" cy="381000"/>
+            <a:off x="628650" y="3914775"/>
+            <a:ext cx="10953750" cy="438150"/>
           </a:xfrm>
           <a:prstGeom xmlns:a="http://schemas.openxmlformats.org/drawingml/2006/main" prst="rect">
             <a:avLst/>
@@ -1928,13 +1833,13 @@
           </a:ln>
         </p:spPr>
         <p:txBody>
-          <a:bodyPr xmlns:a="http://schemas.openxmlformats.org/drawingml/2006/main">
+          <a:bodyPr xmlns:a="http://schemas.openxmlformats.org/drawingml/2006/main" anchor="ctr">
             <a:noAutofit/>
           </a:bodyPr>
           <a:lstStyle xmlns:a="http://schemas.openxmlformats.org/drawingml/2006/main"/>
           <a:p xmlns:a="http://schemas.openxmlformats.org/drawingml/2006/main">
             <a:pPr>
-              <a:defRPr sz="2175" b="1">
+              <a:defRPr sz="2250" b="1">
                 <a:solidFill>
                   <a:srgbClr val="172D42"/>
                 </a:solidFill>
@@ -1944,7 +1849,7 @@
               </a:defRPr>
             </a:pPr>
             <a:r>
-              <a:rPr sz="2175" b="1">
+              <a:rPr sz="2250" b="1">
                 <a:solidFill>
                   <a:srgbClr val="172D42"/>
                 </a:solidFill>
@@ -1952,17 +1857,17 @@
                 <a:ea typeface="Arial"/>
                 <a:cs typeface="Arial"/>
               </a:rPr>
-              <a:t>Demo: Terrapin Touring Co.</a:t>
-            </a:r>
-          </a:p>
-        </p:txBody>
-      </p:sp>
-      <p:sp>
-        <p:nvSpPr>
-          <p:cNvPr id="16" name="baseline-label">
+              <a:t>Terrapin keeps both handoffs</a:t>
+            </a:r>
+          </a:p>
+        </p:txBody>
+      </p:sp>
+      <p:sp>
+        <p:nvSpPr>
+          <p:cNvPr id="13" name="">
             <a:extLst xmlns:a="http://schemas.openxmlformats.org/drawingml/2006/main">
               <a:ext uri="{FF2B5EF4-FFF2-40B4-BE49-F238E27FC236}">
-                <a16:creationId xmlns:a16="http://schemas.microsoft.com/office/drawing/2014/main" id="{72AACBF5-E583-48B4-AC18-05CF77CABBCC}"/>
+                <a16:creationId xmlns:a16="http://schemas.microsoft.com/office/drawing/2014/main" id="{28573A89-430E-4C5D-9B1E-BF3576B012D3}"/>
               </a:ext>
             </a:extLst>
           </p:cNvPr>
@@ -1973,8 +1878,8 @@
         </p:nvSpPr>
         <p:spPr>
           <a:xfrm xmlns:a="http://schemas.openxmlformats.org/drawingml/2006/main">
-            <a:off x="571500" y="4533900"/>
-            <a:ext cx="2809875" cy="304800"/>
+            <a:off x="628650" y="4438650"/>
+            <a:ext cx="4810125" cy="314325"/>
           </a:xfrm>
           <a:prstGeom xmlns:a="http://schemas.openxmlformats.org/drawingml/2006/main" prst="rect">
             <a:avLst/>
@@ -1985,13 +1890,13 @@
           </a:ln>
         </p:spPr>
         <p:txBody>
-          <a:bodyPr xmlns:a="http://schemas.openxmlformats.org/drawingml/2006/main">
+          <a:bodyPr xmlns:a="http://schemas.openxmlformats.org/drawingml/2006/main" anchor="ctr">
             <a:noAutofit/>
           </a:bodyPr>
           <a:lstStyle xmlns:a="http://schemas.openxmlformats.org/drawingml/2006/main"/>
           <a:p xmlns:a="http://schemas.openxmlformats.org/drawingml/2006/main">
             <a:pPr>
-              <a:defRPr sz="1725" b="0">
+              <a:defRPr sz="1613" b="0">
                 <a:solidFill>
                   <a:srgbClr val="53606A"/>
                 </a:solidFill>
@@ -2001,7 +1906,7 @@
               </a:defRPr>
             </a:pPr>
             <a:r>
-              <a:rPr sz="1725" b="0">
+              <a:rPr sz="1613" b="0">
                 <a:solidFill>
                   <a:srgbClr val="53606A"/>
                 </a:solidFill>
@@ -2009,17 +1914,17 @@
                 <a:ea typeface="Arial"/>
                 <a:cs typeface="Arial"/>
               </a:rPr>
-              <a:t>Python baseline</a:t>
-            </a:r>
-          </a:p>
-        </p:txBody>
-      </p:sp>
-      <p:sp>
-        <p:nvSpPr>
-          <p:cNvPr id="17" name="final-label">
+              <a:t>September 16, 2026</a:t>
+            </a:r>
+          </a:p>
+        </p:txBody>
+      </p:sp>
+      <p:sp>
+        <p:nvSpPr>
+          <p:cNvPr id="14" name="">
             <a:extLst xmlns:a="http://schemas.openxmlformats.org/drawingml/2006/main">
               <a:ext uri="{FF2B5EF4-FFF2-40B4-BE49-F238E27FC236}">
-                <a16:creationId xmlns:a16="http://schemas.microsoft.com/office/drawing/2014/main" id="{8491760E-94AC-48F2-90D2-D1511790DFAD}"/>
+                <a16:creationId xmlns:a16="http://schemas.microsoft.com/office/drawing/2014/main" id="{F557CCD3-A000-4C06-808F-545A4F74335D}"/>
               </a:ext>
             </a:extLst>
           </p:cNvPr>
@@ -2030,8 +1935,8 @@
         </p:nvSpPr>
         <p:spPr>
           <a:xfrm xmlns:a="http://schemas.openxmlformats.org/drawingml/2006/main">
-            <a:off x="3629025" y="4533900"/>
-            <a:ext cx="3333750" cy="304800"/>
+            <a:off x="628650" y="4781550"/>
+            <a:ext cx="4810125" cy="371475"/>
           </a:xfrm>
           <a:prstGeom xmlns:a="http://schemas.openxmlformats.org/drawingml/2006/main" prst="rect">
             <a:avLst/>
@@ -2042,15 +1947,15 @@
           </a:ln>
         </p:spPr>
         <p:txBody>
-          <a:bodyPr xmlns:a="http://schemas.openxmlformats.org/drawingml/2006/main">
+          <a:bodyPr xmlns:a="http://schemas.openxmlformats.org/drawingml/2006/main" anchor="ctr">
             <a:noAutofit/>
           </a:bodyPr>
           <a:lstStyle xmlns:a="http://schemas.openxmlformats.org/drawingml/2006/main"/>
           <a:p xmlns:a="http://schemas.openxmlformats.org/drawingml/2006/main">
             <a:pPr>
-              <a:defRPr sz="1725" b="0">
-                <a:solidFill>
-                  <a:srgbClr val="53606A"/>
+              <a:defRPr sz="1950" b="1">
+                <a:solidFill>
+                  <a:srgbClr val="172D42"/>
                 </a:solidFill>
                 <a:latin typeface="Arial"/>
                 <a:ea typeface="Arial"/>
@@ -2058,25 +1963,25 @@
               </a:defRPr>
             </a:pPr>
             <a:r>
-              <a:rPr sz="1725" b="0">
-                <a:solidFill>
-                  <a:srgbClr val="53606A"/>
+              <a:rPr sz="1950" b="1">
+                <a:solidFill>
+                  <a:srgbClr val="172D42"/>
                 </a:solidFill>
                 <a:latin typeface="Arial"/>
                 <a:ea typeface="Arial"/>
                 <a:cs typeface="Arial"/>
               </a:rPr>
-              <a:t>After note review</a:t>
-            </a:r>
-          </a:p>
-        </p:txBody>
-      </p:sp>
-      <p:sp>
-        <p:nvSpPr>
-          <p:cNvPr id="18" name="baseline-status">
+              <a:t>Sales to Implementation</a:t>
+            </a:r>
+          </a:p>
+        </p:txBody>
+      </p:sp>
+      <p:sp>
+        <p:nvSpPr>
+          <p:cNvPr id="15" name="">
             <a:extLst xmlns:a="http://schemas.openxmlformats.org/drawingml/2006/main">
               <a:ext uri="{FF2B5EF4-FFF2-40B4-BE49-F238E27FC236}">
-                <a16:creationId xmlns:a16="http://schemas.microsoft.com/office/drawing/2014/main" id="{6632A932-61FA-4C4C-8F9A-ABA21ADDC3DC}"/>
+                <a16:creationId xmlns:a16="http://schemas.microsoft.com/office/drawing/2014/main" id="{691E3A4C-DCB3-48C3-BE78-09AF2BA3EBA0}"/>
               </a:ext>
             </a:extLst>
           </p:cNvPr>
@@ -2087,8 +1992,8 @@
         </p:nvSpPr>
         <p:spPr>
           <a:xfrm xmlns:a="http://schemas.openxmlformats.org/drawingml/2006/main">
-            <a:off x="571500" y="4876800"/>
-            <a:ext cx="2667000" cy="428625"/>
+            <a:off x="628650" y="5172075"/>
+            <a:ext cx="4810125" cy="419100"/>
           </a:xfrm>
           <a:prstGeom xmlns:a="http://schemas.openxmlformats.org/drawingml/2006/main" prst="rect">
             <a:avLst/>
@@ -2099,15 +2004,15 @@
           </a:ln>
         </p:spPr>
         <p:txBody>
-          <a:bodyPr xmlns:a="http://schemas.openxmlformats.org/drawingml/2006/main">
+          <a:bodyPr xmlns:a="http://schemas.openxmlformats.org/drawingml/2006/main" anchor="ctr">
             <a:noAutofit/>
           </a:bodyPr>
           <a:lstStyle xmlns:a="http://schemas.openxmlformats.org/drawingml/2006/main"/>
           <a:p xmlns:a="http://schemas.openxmlformats.org/drawingml/2006/main">
             <a:pPr>
-              <a:defRPr sz="2550" b="1">
-                <a:solidFill>
-                  <a:srgbClr val="172D42"/>
+              <a:defRPr sz="2400" b="1">
+                <a:solidFill>
+                  <a:srgbClr val="225344"/>
                 </a:solidFill>
                 <a:latin typeface="Arial"/>
                 <a:ea typeface="Arial"/>
@@ -2115,9 +2020,9 @@
               </a:defRPr>
             </a:pPr>
             <a:r>
-              <a:rPr sz="2550" b="1">
-                <a:solidFill>
-                  <a:srgbClr val="172D42"/>
+              <a:rPr sz="2400" b="1">
+                <a:solidFill>
+                  <a:srgbClr val="225344"/>
                 </a:solidFill>
                 <a:latin typeface="Arial"/>
                 <a:ea typeface="Arial"/>
@@ -2130,10 +2035,10 @@
       </p:sp>
       <p:sp>
         <p:nvSpPr>
-          <p:cNvPr id="19" name="final-status">
+          <p:cNvPr id="16" name="">
             <a:extLst xmlns:a="http://schemas.openxmlformats.org/drawingml/2006/main">
               <a:ext uri="{FF2B5EF4-FFF2-40B4-BE49-F238E27FC236}">
-                <a16:creationId xmlns:a16="http://schemas.microsoft.com/office/drawing/2014/main" id="{6DA10AAE-F411-4583-8D97-3FB9CB13A936}"/>
+                <a16:creationId xmlns:a16="http://schemas.microsoft.com/office/drawing/2014/main" id="{6D881BE6-567D-4BE5-85B3-121EE53B8D18}"/>
               </a:ext>
             </a:extLst>
           </p:cNvPr>
@@ -2144,8 +2049,8 @@
         </p:nvSpPr>
         <p:spPr>
           <a:xfrm xmlns:a="http://schemas.openxmlformats.org/drawingml/2006/main">
-            <a:off x="3629025" y="4876800"/>
-            <a:ext cx="3810000" cy="428625"/>
+            <a:off x="6238875" y="4438650"/>
+            <a:ext cx="5334000" cy="314325"/>
           </a:xfrm>
           <a:prstGeom xmlns:a="http://schemas.openxmlformats.org/drawingml/2006/main" prst="rect">
             <a:avLst/>
@@ -2156,15 +2061,15 @@
           </a:ln>
         </p:spPr>
         <p:txBody>
-          <a:bodyPr xmlns:a="http://schemas.openxmlformats.org/drawingml/2006/main">
+          <a:bodyPr xmlns:a="http://schemas.openxmlformats.org/drawingml/2006/main" anchor="ctr">
             <a:noAutofit/>
           </a:bodyPr>
           <a:lstStyle xmlns:a="http://schemas.openxmlformats.org/drawingml/2006/main"/>
           <a:p xmlns:a="http://schemas.openxmlformats.org/drawingml/2006/main">
             <a:pPr>
-              <a:defRPr sz="2550" b="1">
-                <a:solidFill>
-                  <a:srgbClr val="A63646"/>
+              <a:defRPr sz="1613" b="0">
+                <a:solidFill>
+                  <a:srgbClr val="53606A"/>
                 </a:solidFill>
                 <a:latin typeface="Arial"/>
                 <a:ea typeface="Arial"/>
@@ -2172,25 +2077,25 @@
               </a:defRPr>
             </a:pPr>
             <a:r>
-              <a:rPr sz="2550" b="1">
-                <a:solidFill>
-                  <a:srgbClr val="A63646"/>
+              <a:rPr sz="1613" b="0">
+                <a:solidFill>
+                  <a:srgbClr val="53606A"/>
                 </a:solidFill>
                 <a:latin typeface="Arial"/>
                 <a:ea typeface="Arial"/>
                 <a:cs typeface="Arial"/>
               </a:rPr>
-              <a:t>Needs Review</a:t>
-            </a:r>
-          </a:p>
-        </p:txBody>
-      </p:sp>
-      <p:sp>
-        <p:nvSpPr>
-          <p:cNvPr id="20" name="conflict">
+              <a:t>December 1, 2026 (simulated)</a:t>
+            </a:r>
+          </a:p>
+        </p:txBody>
+      </p:sp>
+      <p:sp>
+        <p:nvSpPr>
+          <p:cNvPr id="17" name="">
             <a:extLst xmlns:a="http://schemas.openxmlformats.org/drawingml/2006/main">
               <a:ext uri="{FF2B5EF4-FFF2-40B4-BE49-F238E27FC236}">
-                <a16:creationId xmlns:a16="http://schemas.microsoft.com/office/drawing/2014/main" id="{420DECAD-8F71-479C-B4AC-12C64DAA3915}"/>
+                <a16:creationId xmlns:a16="http://schemas.microsoft.com/office/drawing/2014/main" id="{8BECE10E-7416-4585-9A6D-B251D6657806}"/>
               </a:ext>
             </a:extLst>
           </p:cNvPr>
@@ -2201,8 +2106,8 @@
         </p:nvSpPr>
         <p:spPr>
           <a:xfrm xmlns:a="http://schemas.openxmlformats.org/drawingml/2006/main">
-            <a:off x="571500" y="5505450"/>
-            <a:ext cx="7229475" cy="781050"/>
+            <a:off x="6238875" y="4781550"/>
+            <a:ext cx="5334000" cy="371475"/>
           </a:xfrm>
           <a:prstGeom xmlns:a="http://schemas.openxmlformats.org/drawingml/2006/main" prst="rect">
             <a:avLst/>
@@ -2213,13 +2118,13 @@
           </a:ln>
         </p:spPr>
         <p:txBody>
-          <a:bodyPr xmlns:a="http://schemas.openxmlformats.org/drawingml/2006/main">
+          <a:bodyPr xmlns:a="http://schemas.openxmlformats.org/drawingml/2006/main" anchor="ctr">
             <a:noAutofit/>
           </a:bodyPr>
           <a:lstStyle xmlns:a="http://schemas.openxmlformats.org/drawingml/2006/main"/>
           <a:p xmlns:a="http://schemas.openxmlformats.org/drawingml/2006/main">
             <a:pPr>
-              <a:defRPr sz="1800" b="0">
+              <a:defRPr sz="1875" b="1">
                 <a:solidFill>
                   <a:srgbClr val="172D42"/>
                 </a:solidFill>
@@ -2229,7 +2134,7 @@
               </a:defRPr>
             </a:pPr>
             <a:r>
-              <a:rPr sz="1800" b="0">
+              <a:rPr sz="1875" b="1">
                 <a:solidFill>
                   <a:srgbClr val="172D42"/>
                 </a:solidFill>
@@ -2237,40 +2142,17 @@
                 <a:ea typeface="Arial"/>
                 <a:cs typeface="Arial"/>
               </a:rPr>
-              <a:t>CRM: pilot starts Oct 5. Approved change: Nov 2.</a:t>
-            </a:r>
-          </a:p>
-          <a:p xmlns:a="http://schemas.openxmlformats.org/drawingml/2006/main">
-            <a:pPr>
-              <a:defRPr sz="1800" b="0">
-                <a:solidFill>
-                  <a:srgbClr val="172D42"/>
-                </a:solidFill>
-                <a:latin typeface="Arial"/>
-                <a:ea typeface="Arial"/>
-                <a:cs typeface="Arial"/>
-              </a:defRPr>
-            </a:pPr>
-            <a:r>
-              <a:rPr sz="1800" b="0">
-                <a:solidFill>
-                  <a:srgbClr val="172D42"/>
-                </a:solidFill>
-                <a:latin typeface="Arial"/>
-                <a:ea typeface="Arial"/>
-                <a:cs typeface="Arial"/>
-              </a:rPr>
-              <a:t>The team must reconcile the remaining milestones.</a:t>
-            </a:r>
-          </a:p>
-        </p:txBody>
-      </p:sp>
-      <p:sp>
-        <p:nvSpPr>
-          <p:cNvPr id="21" name="boundary-label">
+              <a:t>Implementation to Customer Success</a:t>
+            </a:r>
+          </a:p>
+        </p:txBody>
+      </p:sp>
+      <p:sp>
+        <p:nvSpPr>
+          <p:cNvPr id="18" name="">
             <a:extLst xmlns:a="http://schemas.openxmlformats.org/drawingml/2006/main">
               <a:ext uri="{FF2B5EF4-FFF2-40B4-BE49-F238E27FC236}">
-                <a16:creationId xmlns:a16="http://schemas.microsoft.com/office/drawing/2014/main" id="{70AE5B6F-2D70-47F9-A707-ABF3F05A7ED6}"/>
+                <a16:creationId xmlns:a16="http://schemas.microsoft.com/office/drawing/2014/main" id="{B8E5A315-FFCF-418B-92C6-0BF83199BEAF}"/>
               </a:ext>
             </a:extLst>
           </p:cNvPr>
@@ -2281,8 +2163,8 @@
         </p:nvSpPr>
         <p:spPr>
           <a:xfrm xmlns:a="http://schemas.openxmlformats.org/drawingml/2006/main">
-            <a:off x="8286750" y="4010025"/>
-            <a:ext cx="3352800" cy="381000"/>
+            <a:off x="6238875" y="5172075"/>
+            <a:ext cx="5334000" cy="419100"/>
           </a:xfrm>
           <a:prstGeom xmlns:a="http://schemas.openxmlformats.org/drawingml/2006/main" prst="rect">
             <a:avLst/>
@@ -2293,15 +2175,15 @@
           </a:ln>
         </p:spPr>
         <p:txBody>
-          <a:bodyPr xmlns:a="http://schemas.openxmlformats.org/drawingml/2006/main">
+          <a:bodyPr xmlns:a="http://schemas.openxmlformats.org/drawingml/2006/main" anchor="ctr">
             <a:noAutofit/>
           </a:bodyPr>
           <a:lstStyle xmlns:a="http://schemas.openxmlformats.org/drawingml/2006/main"/>
           <a:p xmlns:a="http://schemas.openxmlformats.org/drawingml/2006/main">
             <a:pPr>
-              <a:defRPr sz="2025" b="1">
-                <a:solidFill>
-                  <a:srgbClr val="172D42"/>
+              <a:defRPr sz="2400" b="1">
+                <a:solidFill>
+                  <a:srgbClr val="A63646"/>
                 </a:solidFill>
                 <a:latin typeface="Arial"/>
                 <a:ea typeface="Arial"/>
@@ -2309,25 +2191,25 @@
               </a:defRPr>
             </a:pPr>
             <a:r>
-              <a:rPr sz="2025" b="1">
-                <a:solidFill>
-                  <a:srgbClr val="172D42"/>
+              <a:rPr sz="2400" b="1">
+                <a:solidFill>
+                  <a:srgbClr val="A63646"/>
                 </a:solidFill>
                 <a:latin typeface="Arial"/>
                 <a:ea typeface="Arial"/>
                 <a:cs typeface="Arial"/>
               </a:rPr>
-              <a:t>People resolve the gaps</a:t>
-            </a:r>
-          </a:p>
-        </p:txBody>
-      </p:sp>
-      <p:sp>
-        <p:nvSpPr>
-          <p:cNvPr id="22" name="boundary">
+              <a:t>Needs Review</a:t>
+            </a:r>
+          </a:p>
+        </p:txBody>
+      </p:sp>
+      <p:sp>
+        <p:nvSpPr>
+          <p:cNvPr id="19" name="">
             <a:extLst xmlns:a="http://schemas.openxmlformats.org/drawingml/2006/main">
               <a:ext uri="{FF2B5EF4-FFF2-40B4-BE49-F238E27FC236}">
-                <a16:creationId xmlns:a16="http://schemas.microsoft.com/office/drawing/2014/main" id="{86E8B977-E20F-49A8-A58D-C0C6AE7FDE22}"/>
+                <a16:creationId xmlns:a16="http://schemas.microsoft.com/office/drawing/2014/main" id="{DBB1691A-1818-4987-A6CE-311D44869967}"/>
               </a:ext>
             </a:extLst>
           </p:cNvPr>
@@ -2338,8 +2220,8 @@
         </p:nvSpPr>
         <p:spPr>
           <a:xfrm xmlns:a="http://schemas.openxmlformats.org/drawingml/2006/main">
-            <a:off x="8286750" y="4552950"/>
-            <a:ext cx="3352800" cy="1257300"/>
+            <a:off x="628650" y="5743575"/>
+            <a:ext cx="10953750" cy="390525"/>
           </a:xfrm>
           <a:prstGeom xmlns:a="http://schemas.openxmlformats.org/drawingml/2006/main" prst="rect">
             <a:avLst/>
@@ -2350,15 +2232,15 @@
           </a:ln>
         </p:spPr>
         <p:txBody>
-          <a:bodyPr xmlns:a="http://schemas.openxmlformats.org/drawingml/2006/main">
+          <a:bodyPr xmlns:a="http://schemas.openxmlformats.org/drawingml/2006/main" anchor="ctr">
             <a:noAutofit/>
           </a:bodyPr>
           <a:lstStyle xmlns:a="http://schemas.openxmlformats.org/drawingml/2006/main"/>
           <a:p xmlns:a="http://schemas.openxmlformats.org/drawingml/2006/main">
             <a:pPr>
-              <a:defRPr sz="1800" b="0">
-                <a:solidFill>
-                  <a:srgbClr val="53606A"/>
+              <a:defRPr sz="1913" b="0">
+                <a:solidFill>
+                  <a:srgbClr val="172D42"/>
                 </a:solidFill>
                 <a:latin typeface="Arial"/>
                 <a:ea typeface="Arial"/>
@@ -2366,71 +2248,25 @@
               </a:defRPr>
             </a:pPr>
             <a:r>
-              <a:rPr sz="1800" b="0">
-                <a:solidFill>
-                  <a:srgbClr val="53606A"/>
+              <a:rPr sz="1913" b="0">
+                <a:solidFill>
+                  <a:srgbClr val="172D42"/>
                 </a:solidFill>
                 <a:latin typeface="Arial"/>
                 <a:ea typeface="Arial"/>
                 <a:cs typeface="Arial"/>
               </a:rPr>
-              <a:t>The brief cites both sources.</a:t>
-            </a:r>
-          </a:p>
-          <a:p xmlns:a="http://schemas.openxmlformats.org/drawingml/2006/main">
-            <a:pPr>
-              <a:defRPr sz="1800" b="0">
-                <a:solidFill>
-                  <a:srgbClr val="53606A"/>
-                </a:solidFill>
-                <a:latin typeface="Arial"/>
-                <a:ea typeface="Arial"/>
-                <a:cs typeface="Arial"/>
-              </a:defRPr>
-            </a:pPr>
-            <a:r>
-              <a:rPr sz="1800" b="0">
-                <a:solidFill>
-                  <a:srgbClr val="53606A"/>
-                </a:solidFill>
-                <a:latin typeface="Arial"/>
-                <a:ea typeface="Arial"/>
-                <a:cs typeface="Arial"/>
-              </a:rPr>
-              <a:t>The team confirms the plan.</a:t>
-            </a:r>
-          </a:p>
-          <a:p xmlns:a="http://schemas.openxmlformats.org/drawingml/2006/main">
-            <a:pPr>
-              <a:defRPr sz="1800" b="0">
-                <a:solidFill>
-                  <a:srgbClr val="53606A"/>
-                </a:solidFill>
-                <a:latin typeface="Arial"/>
-                <a:ea typeface="Arial"/>
-                <a:cs typeface="Arial"/>
-              </a:defRPr>
-            </a:pPr>
-            <a:r>
-              <a:rPr sz="1800" b="0">
-                <a:solidFill>
-                  <a:srgbClr val="53606A"/>
-                </a:solidFill>
-                <a:latin typeface="Arial"/>
-                <a:ea typeface="Arial"/>
-                <a:cs typeface="Arial"/>
-              </a:rPr>
-              <a:t>No CRM writeback in v1.</a:t>
-            </a:r>
-          </a:p>
-        </p:txBody>
-      </p:sp>
-      <p:sp>
-        <p:nvSpPr>
-          <p:cNvPr id="23" name="fictional">
+              <a:t>Althea owns the account. Ruben’s Dec 18 action stays open.</a:t>
+            </a:r>
+          </a:p>
+        </p:txBody>
+      </p:sp>
+      <p:sp>
+        <p:nvSpPr>
+          <p:cNvPr id="20" name="">
             <a:extLst xmlns:a="http://schemas.openxmlformats.org/drawingml/2006/main">
               <a:ext uri="{FF2B5EF4-FFF2-40B4-BE49-F238E27FC236}">
-                <a16:creationId xmlns:a16="http://schemas.microsoft.com/office/drawing/2014/main" id="{1EF34044-2447-4BC2-8317-BBBAA8A01B06}"/>
+                <a16:creationId xmlns:a16="http://schemas.microsoft.com/office/drawing/2014/main" id="{767E6B7A-5BF6-474B-B607-FE82C94DF506}"/>
               </a:ext>
             </a:extLst>
           </p:cNvPr>
@@ -2441,8 +2277,8 @@
         </p:nvSpPr>
         <p:spPr>
           <a:xfrm xmlns:a="http://schemas.openxmlformats.org/drawingml/2006/main">
-            <a:off x="8286750" y="6057900"/>
-            <a:ext cx="3352800" cy="342900"/>
+            <a:off x="628650" y="6334125"/>
+            <a:ext cx="10953750" cy="285750"/>
           </a:xfrm>
           <a:prstGeom xmlns:a="http://schemas.openxmlformats.org/drawingml/2006/main" prst="rect">
             <a:avLst/>
@@ -2453,13 +2289,13 @@
           </a:ln>
         </p:spPr>
         <p:txBody>
-          <a:bodyPr xmlns:a="http://schemas.openxmlformats.org/drawingml/2006/main">
+          <a:bodyPr xmlns:a="http://schemas.openxmlformats.org/drawingml/2006/main" anchor="ctr">
             <a:noAutofit/>
           </a:bodyPr>
           <a:lstStyle xmlns:a="http://schemas.openxmlformats.org/drawingml/2006/main"/>
           <a:p xmlns:a="http://schemas.openxmlformats.org/drawingml/2006/main">
             <a:pPr>
-              <a:defRPr sz="1725" b="0">
+              <a:defRPr sz="1313" b="0">
                 <a:solidFill>
                   <a:srgbClr val="53606A"/>
                 </a:solidFill>
@@ -2469,7 +2305,7 @@
               </a:defRPr>
             </a:pPr>
             <a:r>
-              <a:rPr sz="1725" b="0">
+              <a:rPr sz="1313" b="0">
                 <a:solidFill>
                   <a:srgbClr val="53606A"/>
                 </a:solidFill>
@@ -2477,7 +2313,7 @@
                 <a:ea typeface="Arial"/>
                 <a:cs typeface="Arial"/>
               </a:rPr>
-              <a:t>Fictional demo data</a:t>
+              <a:t>No automatic CRM trigger or writeback. Fictional records. Business benefit is unmeasured.</a:t>
             </a:r>
           </a:p>
         </p:txBody>
@@ -2485,7 +2321,7 @@
     </p:spTree>
     <p:extLst>
       <p:ext uri="{BB962C8B-B14F-4D97-AF65-F5344CB8AC3E}">
-        <p14:creationId xmlns:p14="http://schemas.microsoft.com/office/powerpoint/2010/main" val="681122921"/>
+        <p14:creationId xmlns:p14="http://schemas.microsoft.com/office/powerpoint/2010/main" val="1541372204"/>
       </p:ext>
     </p:extLst>
   </p:cSld>

</xml_diff>